<commit_message>
Automatiza demonstração e bateria com cinco repetições e falhas aleatórias
</commit_message>
<xml_diff>
--- a/docs/apresentacao.pptx
+++ b/docs/apresentacao.pptx
@@ -2,20 +2,20 @@
 <file path=ppt/presentation.xml><?xml version="1.0" encoding="utf-8"?>
 <p:presentation xmlns:p="http://schemas.openxmlformats.org/presentationml/2006/main">
   <p:sldMasterIdLst>
-    <p:sldMasterId xmlns:r="http://schemas.openxmlformats.org/officeDocument/2006/relationships" id="2147483648" r:id="R8f841a38d8e94ca2"/>
+    <p:sldMasterId xmlns:r="http://schemas.openxmlformats.org/officeDocument/2006/relationships" id="2147483648" r:id="Rcc7be76d0ce247db"/>
   </p:sldMasterIdLst>
   <p:notesMasterIdLst>
-    <p:notesMasterId xmlns:r="http://schemas.openxmlformats.org/officeDocument/2006/relationships" r:id="R1b809a89b023403c"/>
+    <p:notesMasterId xmlns:r="http://schemas.openxmlformats.org/officeDocument/2006/relationships" r:id="Rab0d89dc5e4a4810"/>
   </p:notesMasterIdLst>
   <p:sldIdLst>
-    <p:sldId xmlns:r="http://schemas.openxmlformats.org/officeDocument/2006/relationships" id="256" r:id="R255cdb16c9374d3c"/>
-    <p:sldId xmlns:r="http://schemas.openxmlformats.org/officeDocument/2006/relationships" id="257" r:id="R16741fe6cc72449a"/>
-    <p:sldId xmlns:r="http://schemas.openxmlformats.org/officeDocument/2006/relationships" id="258" r:id="R84a343549b0d4af1"/>
-    <p:sldId xmlns:r="http://schemas.openxmlformats.org/officeDocument/2006/relationships" id="259" r:id="Rf8cd7d2c8cdf49f1"/>
-    <p:sldId xmlns:r="http://schemas.openxmlformats.org/officeDocument/2006/relationships" id="260" r:id="Rec4de05eb9fa40f8"/>
-    <p:sldId xmlns:r="http://schemas.openxmlformats.org/officeDocument/2006/relationships" id="261" r:id="Rc675f9afae9d4abc"/>
-    <p:sldId xmlns:r="http://schemas.openxmlformats.org/officeDocument/2006/relationships" id="262" r:id="Rf553f747318c4f01"/>
-    <p:sldId xmlns:r="http://schemas.openxmlformats.org/officeDocument/2006/relationships" id="263" r:id="R9a12e4a458d045a0"/>
+    <p:sldId xmlns:r="http://schemas.openxmlformats.org/officeDocument/2006/relationships" id="256" r:id="R080ad70cef314066"/>
+    <p:sldId xmlns:r="http://schemas.openxmlformats.org/officeDocument/2006/relationships" id="257" r:id="Rb56bf34f883b47eb"/>
+    <p:sldId xmlns:r="http://schemas.openxmlformats.org/officeDocument/2006/relationships" id="258" r:id="R0f80e890a3b240c0"/>
+    <p:sldId xmlns:r="http://schemas.openxmlformats.org/officeDocument/2006/relationships" id="259" r:id="Rc7fc9d18a3c34513"/>
+    <p:sldId xmlns:r="http://schemas.openxmlformats.org/officeDocument/2006/relationships" id="260" r:id="R3b2e09259fe34ace"/>
+    <p:sldId xmlns:r="http://schemas.openxmlformats.org/officeDocument/2006/relationships" id="261" r:id="R3a58ae6d91834ff0"/>
+    <p:sldId xmlns:r="http://schemas.openxmlformats.org/officeDocument/2006/relationships" id="262" r:id="R009b804a54384d32"/>
+    <p:sldId xmlns:r="http://schemas.openxmlformats.org/officeDocument/2006/relationships" id="263" r:id="Rd9b3da56f7c14483"/>
   </p:sldIdLst>
   <p:sldSz cx="12192000" cy="6858000"/>
   <p:notesSz cx="6858000" cy="9144000"/>
@@ -744,7 +744,7 @@
           <a:lstStyle xmlns:a="http://schemas.openxmlformats.org/drawingml/2006/main"/>
           <a:p xmlns:a="http://schemas.openxmlformats.org/drawingml/2006/main">
             <a:r>
-              <a:t>24 combinações: 2/4 peers, blocos de 1.024/4.096 bytes e arquivos de 10/20 KiB, 1/5/10/20 MiB. Todos os ensaios usam malha completa. Os logs verificam que cada leecher se conectou a todos os vizinhos, e que índices, fontes, tamanho e SHA-256 estão corretos. Processos independentes em TCP loopback; uma execução por configuração.</a:t>
+              <a:t>24 configurações x 5 repetições = 120 execuções. Dois/quatro peers, blocos de 1.024/4.096 bytes e arquivos de 10/20 KiB, 1/5/10/20 MiB. Malha completa. Ordem embaralhada por repetição, arquivos pseudoaleatórios replicáveis com seed 2026. Verificação de tamanho, SHA-256, índices, fontes e conexão a todos os vizinhos. Processos independentes em TCP loopback. Comando: python3 executar.py --testes --repeticoes 5 --seed 2026.</a:t>
             </a:r>
           </a:p>
           <a:p xmlns:a="http://schemas.openxmlformats.org/drawingml/2006/main">
@@ -819,7 +819,7 @@
           <a:lstStyle xmlns:a="http://schemas.openxmlformats.org/drawingml/2006/main"/>
           <a:p xmlns:a="http://schemas.openxmlformats.org/drawingml/2006/main">
             <a:r>
-              <a:t>Dados da execução de 30/10/2026 em resultados/resumo.json. [{"peers":2,"block":1024,"seconds":3.1995},{"peers":4,"block":1024,"seconds":10.2469},{"peers":2,"block":4096,"seconds":1.5319},{"peers":4,"block":4096,"seconds":5.0194}]. Quatro peers entregam três cópias em malha completa. Os tempos incluem inicialização, logs e espera pelo contato com todos os vizinhos; uma medição por caso, sem inferir desempenho em LAN/WAN.</a:t>
+              <a:t>Médias e desvios calculados automaticamente dos cinco tempos por configuração em resultados/estatisticas.json: [{"peers":2,"block_bytes":1024,"size_bytes":20971520,"repetitions":5,"mean_seconds":4.05026,"std_seconds":0.7943199091046377,"min_seconds":3.3614,"max_seconds":5.141,"seconds":[5.141,3.7553,3.3614,4.616,3.3776],"integrity":"PASS","topology":"mesh"},{"peers":4,"block_bytes":1024,"size_bytes":20971520,"repetitions":5,"mean_seconds":9.61766,"std_seconds":1.6812387941633995,"min_seconds":7.4895,"max_seconds":11.3061,"seconds":[11.3015,11.3061,8.5974,7.4895,9.3938],"integrity":"PASS","topology":"mesh"},{"peers":2,"block_bytes":4096,"size_bytes":20971520,"repetitions":5,"mean_seconds":1.343,"std_seconds":0.19280001296680455,"min_seconds":1.1294,"max_seconds":1.5704,"seconds":[1.1294,1.2537,1.2384,1.5704,1.5231],"integrity":"PASS","topology":"mesh"},{"peers":4,"block_bytes":4096,"size_bytes":20971520,"repetitions":5,"mean_seconds":2.6962,"std_seconds":0.5765892298681965,"min_seconds":2.1876,"max_seconds":3.412,"seconds":[2.4346,3.412,3.2178,2.1876,2.229],"integrity":"PASS","topology":"mesh"}]. Desvio-padrão amostral, denominador n-1. Quatro peers entregam três cópias. Inclui inicialização, logs e contato com todos os vizinhos. Sem inferência de desempenho em LAN/WAN.</a:t>
             </a:r>
           </a:p>
           <a:p xmlns:a="http://schemas.openxmlformats.org/drawingml/2006/main">
@@ -894,7 +894,7 @@
           <a:lstStyle xmlns:a="http://schemas.openxmlformats.org/drawingml/2006/main"/>
           <a:p xmlns:a="http://schemas.openxmlformats.org/drawingml/2006/main">
             <a:r>
-              <a:t>Os dois testes usam SIGKILL real durante downloads incompletos, com quatro peers em malha. No temporário, a única semente cai, os leechers preservam seus blocos em memória/disco e reconectam quando ela reinicia. No permanente, há duas sementes iniciais; uma cai e os três processos restantes concluem sem seu retorno. Ter cópias disponíveis é necessário para tolerar perda permanente. Tamanho e SHA-256 conferidos em todos os arquivos dos processos ativos; índices sem duplicação. Também passaram compartilhamento parcial, seeder tardio e múltiplas fontes. Evidência: resultados/queda_temporaria e resultados/queda_permanente.</a:t>
+              <a:t>Cinco sorteios reproduzíveis entre quatro peers, seeds 0 a 4. SIGKILL aplicado enquanto downloads dos sobreviventes ainda estavam incompletos e após observar dados recebidos do peer escolhido. Duas sementes iniciais garantem disponibilidade. Os sobreviventes receberam novos blocos de outras fontes e concluíram sem reiniciar o peer morto. Dados: [{"seed":0,"peer":3,"blocks":{"2":402},"sources":{"2":[38031,43499]},"seconds":0.8297,"hash":"9fd6bacd218559526a9fc1abd35692c465fede0352bc1ce148c8eecce6ec6081"},{"seed":1,"peer":1,"blocks":{"2":488,"3":487},"sources":{"2":[36089,45867],"3":[36089,46947,51943]},"seconds":1.7487,"hash":"6a8529956c7a3c8926785a34bf6e4527a0193725b1aa43e8d96ff26943c9fbfd"},{"seed":2,"peer":0,"blocks":{"2":449,"3":462},"sources":{"2":[45089,60595],"3":[41481,45089,59655]},"seconds":1.3939,"hash":"c1208dd98a06878af2b6d19f1e3ed46275d0af1d3cdcfac5e4436e7a8e73d617"},{"seed":3,"peer":1,"blocks":{"2":475,"3":493},"sources":{"2":[41419,44605],"3":[44605,45605]},"seconds":1.654,"hash":"c068aedf351f92f867fc32fb74552f81b2c1b05711a31ff151a06eeb3f5b86f2"},{"seed":4,"peer":1,"blocks":{"2":472,"3":454},"sources":{"2":[38713,48885],"3":[38713,48055]},"seconds":1.1411,"hash":"bd2b917729e756f7f55137f5ddc52c727f87edca06b9bdf8ef3e0a86593431d0"}]. Também passaram queda temporária da única semente, queda permanente controlada, redistribuição parcial, início tardio e malha completa. Total: 130 integrações e 11 unitários.</a:t>
             </a:r>
           </a:p>
           <a:p xmlns:a="http://schemas.openxmlformats.org/drawingml/2006/main">
@@ -969,7 +969,7 @@
           <a:lstStyle xmlns:a="http://schemas.openxmlformats.org/drawingml/2006/main"/>
           <a:p xmlns:a="http://schemas.openxmlformats.org/drawingml/2006/main">
             <a:r>
-              <a:t>Na raiz do projeto, executar python3 tests/integration.py --demo. O comando abre quatro processos, mostra portas e progresso no momento da queda e executa dois cenários. Primeiro: única semente morta e reiniciada. Segundo: uma de duas sementes morta sem retorno. Observar peer_offline, peer_reiniciado e integridade_confirmada. O comando valida os arquivos automaticamente e encerra os processos. Logs em resultados/demo. Augusto pode acompanhar o terminal por compartilhamento de tela. Ensaio entre máquinas remotas não foi realizado. Reiniciar um leecher ainda descarta o parcial; o teste mantém os leechers ativos.</a:t>
+              <a:t>Executar python3 executar.py na raiz. O programa gera arquivo/metadados, inicia quatro processos em malha, mata e reinicia a única semente no primeiro cenário; no segundo sorteia um peer e mata sem retorno, com duas sementes iniciais. Confere tamanho e SHA-256 e encerra todos os processos automaticamente. Não é preciso abrir terminais adicionais. Para repetir o sorteio usar --demo --seed 0. Logs em resultados/demo. Augusto acompanha por compartilhamento de tela. O peer individual continua servindo para os demais; o executor encerra a rede ao fim. Reiniciar o próprio leecher descarta seu parcial.</a:t>
             </a:r>
           </a:p>
           <a:p xmlns:a="http://schemas.openxmlformats.org/drawingml/2006/main">
@@ -3417,12 +3417,12 @@
   </p:cSld>
   <p:clrMap bg1="lt1" tx1="dk1" bg2="lt2" tx2="dk2" accent1="accent1" accent2="accent2" accent3="accent3" accent4="accent4" accent5="accent5" accent6="accent6" hlink="hlink" folHlink="folHlink"/>
   <p:sldLayoutIdLst>
-    <p:sldLayoutId xmlns:r="http://schemas.openxmlformats.org/officeDocument/2006/relationships" id="2147483649" r:id="Rc8b1e127fcfb429e"/>
-    <p:sldLayoutId xmlns:r="http://schemas.openxmlformats.org/officeDocument/2006/relationships" id="2147483650" r:id="R88c3bf29e3f446ad"/>
-    <p:sldLayoutId xmlns:r="http://schemas.openxmlformats.org/officeDocument/2006/relationships" id="2147483651" r:id="Recd613bff3c94900"/>
-    <p:sldLayoutId xmlns:r="http://schemas.openxmlformats.org/officeDocument/2006/relationships" id="2147483652" r:id="Rbafff9d812be46a8"/>
-    <p:sldLayoutId xmlns:r="http://schemas.openxmlformats.org/officeDocument/2006/relationships" id="2147483653" r:id="Ra860aa55203e4a16"/>
-    <p:sldLayoutId xmlns:r="http://schemas.openxmlformats.org/officeDocument/2006/relationships" id="2147483654" r:id="R22abc30367d84a48"/>
+    <p:sldLayoutId xmlns:r="http://schemas.openxmlformats.org/officeDocument/2006/relationships" id="2147483649" r:id="Rd8b4b72b4e314ac0"/>
+    <p:sldLayoutId xmlns:r="http://schemas.openxmlformats.org/officeDocument/2006/relationships" id="2147483650" r:id="R3143612235fc48f4"/>
+    <p:sldLayoutId xmlns:r="http://schemas.openxmlformats.org/officeDocument/2006/relationships" id="2147483651" r:id="Ref444c722afc4a7a"/>
+    <p:sldLayoutId xmlns:r="http://schemas.openxmlformats.org/officeDocument/2006/relationships" id="2147483652" r:id="Ra24912a46abd4a89"/>
+    <p:sldLayoutId xmlns:r="http://schemas.openxmlformats.org/officeDocument/2006/relationships" id="2147483653" r:id="Rc10395e5bf41480c"/>
+    <p:sldLayoutId xmlns:r="http://schemas.openxmlformats.org/officeDocument/2006/relationships" id="2147483654" r:id="Rea0bcf2a7c21441c"/>
   </p:sldLayoutIdLst>
   <p:txStyles>
     <p:titleStyle>
@@ -3991,10 +3991,10 @@
                 <c:formatCode>General</c:formatCode>
                 <c:ptCount val="2"/>
                 <c:pt idx="0">
-                  <c:v>3.1995</c:v>
+                  <c:v>4.05026</c:v>
                 </c:pt>
                 <c:pt idx="1">
-                  <c:v>10.2469</c:v>
+                  <c:v>9.61766</c:v>
                 </c:pt>
               </c:numCache>
             </c:numRef>
@@ -4033,10 +4033,10 @@
                 <c:formatCode>General</c:formatCode>
                 <c:ptCount val="2"/>
                 <c:pt idx="0">
-                  <c:v>1.5319</c:v>
+                  <c:v>1.343</c:v>
                 </c:pt>
                 <c:pt idx="1">
-                  <c:v>5.0194</c:v>
+                  <c:v>2.6962</c:v>
                 </c:pt>
               </c:numCache>
             </c:numRef>
@@ -4254,7 +4254,7 @@
           <p:cNvPr id="6" name="">
             <a:extLst xmlns:a="http://schemas.openxmlformats.org/drawingml/2006/main">
               <a:ext uri="{FF2B5EF4-FFF2-40B4-BE49-F238E27FC236}">
-                <a16:creationId xmlns:a16="http://schemas.microsoft.com/office/drawing/2014/main" id="{0BC4BCA1-F7B6-4A27-8F46-8961F0AA3D0A}"/>
+                <a16:creationId xmlns:a16="http://schemas.microsoft.com/office/drawing/2014/main" id="{F45F6A9D-1D19-43F1-A830-2A7416D79B3D}"/>
               </a:ext>
             </a:extLst>
           </p:cNvPr>
@@ -4264,7 +4264,7 @@
           <p:nvPr/>
         </p:nvPicPr>
         <p:blipFill>
-          <a:blip xmlns:r="http://schemas.openxmlformats.org/officeDocument/2006/relationships" xmlns:a="http://schemas.openxmlformats.org/drawingml/2006/main" r:embed="R673162d0edc843da"/>
+          <a:blip xmlns:r="http://schemas.openxmlformats.org/officeDocument/2006/relationships" xmlns:a="http://schemas.openxmlformats.org/drawingml/2006/main" r:embed="Ra3e52bd894384b8c"/>
           <a:stretch xmlns:a="http://schemas.openxmlformats.org/drawingml/2006/main"/>
         </p:blipFill>
         <p:spPr>
@@ -9541,7 +9541,7 @@
           <p:cNvPr id="4" name="">
             <a:extLst xmlns:a="http://schemas.openxmlformats.org/drawingml/2006/main">
               <a:ext uri="{FF2B5EF4-FFF2-40B4-BE49-F238E27FC236}">
-                <a16:creationId xmlns:a16="http://schemas.microsoft.com/office/drawing/2014/main" id="{EDCA4D40-945F-4205-AAE8-767CE24EC80C}"/>
+                <a16:creationId xmlns:a16="http://schemas.microsoft.com/office/drawing/2014/main" id="{18C0A898-8678-47CE-BE26-682F917E6776}"/>
               </a:ext>
             </a:extLst>
           </p:cNvPr>
@@ -10519,7 +10519,7 @@
                 <a:ea typeface="Lato"/>
                 <a:cs typeface="Lato"/>
               </a:rPr>
-              <a:t>Matriz de testes em malha completa</a:t>
+              <a:t>Matriz em malha: cinco repetições</a:t>
             </a:r>
           </a:p>
         </p:txBody>
@@ -10851,7 +10851,7 @@
                 <a:ea typeface="Lato"/>
                 <a:cs typeface="Lato"/>
               </a:rPr>
-              <a:t>24</a:t>
+              <a:t>120</a:t>
             </a:r>
           </a:p>
         </p:txBody>
@@ -11017,7 +11017,7 @@
                 <a:ea typeface="Lato"/>
                 <a:cs typeface="Lato"/>
               </a:rPr>
-              <a:t>combinações</a:t>
+              <a:t>execuções</a:t>
             </a:r>
           </a:p>
           <a:p xmlns:a="http://schemas.openxmlformats.org/drawingml/2006/main">
@@ -11207,7 +11207,7 @@
                 <a:ea typeface="Lato"/>
                 <a:cs typeface="Lato"/>
               </a:rPr>
-              <a:t>2 e 4 peers</a:t>
+              <a:t>2/4 peers · 5 repetições</a:t>
             </a:r>
           </a:p>
         </p:txBody>
@@ -11924,7 +11924,7 @@
                 <a:ea typeface="Lato"/>
                 <a:cs typeface="Lato"/>
               </a:rPr>
-              <a:t>Tempo de transferência em malha — 20 MiB</a:t>
+              <a:t>Tempo médio em malha — 20 MiB</a:t>
             </a:r>
           </a:p>
         </p:txBody>
@@ -12100,7 +12100,7 @@
           <p:cNvPr id="3" name="Chart">
             <a:extLst xmlns:a="http://schemas.openxmlformats.org/drawingml/2006/main">
               <a:ext uri="{FF2B5EF4-FFF2-40B4-BE49-F238E27FC236}">
-                <a16:creationId xmlns:a16="http://schemas.microsoft.com/office/drawing/2014/main" id="{A43D4714-B4A8-46E2-859B-DE05A40417DD}"/>
+                <a16:creationId xmlns:a16="http://schemas.microsoft.com/office/drawing/2014/main" id="{BFD24833-D581-47A6-9FBE-59BBCFC250F7}"/>
               </a:ext>
             </a:extLst>
           </p:cNvPr>
@@ -12113,7 +12113,7 @@
         </p:xfrm>
         <a:graphic xmlns:a="http://schemas.openxmlformats.org/drawingml/2006/main">
           <a:graphicData uri="http://schemas.openxmlformats.org/drawingml/2006/chart">
-            <c:chart xmlns:r="http://schemas.openxmlformats.org/officeDocument/2006/relationships" xmlns:c="http://schemas.openxmlformats.org/drawingml/2006/chart" r:id="Re53a6cb467f740f2"/>
+            <c:chart xmlns:r="http://schemas.openxmlformats.org/officeDocument/2006/relationships" xmlns:c="http://schemas.openxmlformats.org/drawingml/2006/chart" r:id="Rd6de7bbfa95347de"/>
           </a:graphicData>
         </a:graphic>
       </p:graphicFrame>
@@ -12278,7 +12278,7 @@
                 <a:ea typeface="Lato"/>
                 <a:cs typeface="Lato"/>
               </a:rPr>
-              <a:t>Uma execução por caso em loopback, incluindo inicialização e logs.</a:t>
+              <a:t>Desvio-padrão (1 / 4 KiB): 2 peers ± 0.79 / 0.19 s; 4 peers ± 1.68 / 0.58 s</a:t>
             </a:r>
           </a:p>
         </p:txBody>
@@ -12805,7 +12805,7 @@
                 <a:ea typeface="Lato"/>
                 <a:cs typeface="Lato"/>
               </a:rPr>
-              <a:t>2</a:t>
+              <a:t>5</a:t>
             </a:r>
           </a:p>
         </p:txBody>
@@ -12971,7 +12971,7 @@
                 <a:ea typeface="Lato"/>
                 <a:cs typeface="Lato"/>
               </a:rPr>
-              <a:t>quedas durante</a:t>
+              <a:t>quedas com</a:t>
             </a:r>
           </a:p>
           <a:p xmlns:a="http://schemas.openxmlformats.org/drawingml/2006/main">
@@ -12995,7 +12995,7 @@
                 <a:ea typeface="Lato"/>
                 <a:cs typeface="Lato"/>
               </a:rPr>
-              <a:t>o download</a:t>
+              <a:t>peer sorteado</a:t>
             </a:r>
           </a:p>
         </p:txBody>
@@ -13161,7 +13161,7 @@
                 <a:ea typeface="Lato"/>
                 <a:cs typeface="Lato"/>
               </a:rPr>
-              <a:t>Queda temporária</a:t>
+              <a:t>Sorteio entre A, B, C e D</a:t>
             </a:r>
           </a:p>
         </p:txBody>
@@ -13327,7 +13327,7 @@
                 <a:ea typeface="Lato"/>
                 <a:cs typeface="Lato"/>
               </a:rPr>
-              <a:t>Reconexão após o retorno da única semente.</a:t>
+              <a:t>Outras fontes completaram os arquivos.</a:t>
             </a:r>
           </a:p>
         </p:txBody>
@@ -13493,7 +13493,7 @@
                 <a:ea typeface="Lato"/>
                 <a:cs typeface="Lato"/>
               </a:rPr>
-              <a:t>Queda permanente</a:t>
+              <a:t>Hash e tamanho preservados</a:t>
             </a:r>
           </a:p>
         </p:txBody>
@@ -13659,7 +13659,7 @@
                 <a:ea typeface="Lato"/>
                 <a:cs typeface="Lato"/>
               </a:rPr>
-              <a:t>Conclusão por outra fonte, com duas sementes.</a:t>
+              <a:t>5/5 quedas aleatórias aprovadas.</a:t>
             </a:r>
           </a:p>
         </p:txBody>
@@ -13825,7 +13825,7 @@
                 <a:ea typeface="Lato"/>
                 <a:cs typeface="Lato"/>
               </a:rPr>
-              <a:t>29 cenários de integração + 11 testes unitários aprovados</a:t>
+              <a:t>130 integrações + 11 testes unitários aprovados</a:t>
             </a:r>
           </a:p>
         </p:txBody>
@@ -14518,7 +14518,7 @@
                 <a:ea typeface="Lato"/>
                 <a:cs typeface="Lato"/>
               </a:rPr>
-              <a:t>python3 tests/integration.py --demo</a:t>
+              <a:t>python3 executar.py</a:t>
             </a:r>
           </a:p>
         </p:txBody>

</xml_diff>